<commit_message>
fix: clear the CodeQL notes and tighten sparse cards
The last line label is ink on a light chip, and comparison, split, timeline and takeaway cards are sized to their content and centered. Unused aliases and a no-effect protocol body are gone.

Co-authored-by: Santosh Shinde <santoshshinde2012@gmail.com>
</commit_message>
<xml_diff>
--- a/docs/examples/layout-gallery-graphite.pptx
+++ b/docs/examples/layout-gallery-graphite.pptx
@@ -252,7 +252,11 @@
             </c:dLbl>
             <c:dLbl>
               <c:idx val="2"/>
-              <c:spPr/>
+              <c:spPr>
+                <a:solidFill>
+                  <a:srgbClr val="FFFFFF"/>
+                </a:solidFill>
+              </c:spPr>
               <c:txPr>
                 <a:bodyPr/>
                 <a:lstStyle/>
@@ -260,7 +264,7 @@
                   <a:pPr>
                     <a:defRPr sz="1200" b="1">
                       <a:solidFill>
-                        <a:srgbClr val="B45309"/>
+                        <a:srgbClr val="111113"/>
                       </a:solidFill>
                       <a:latin typeface="Calibri"/>
                     </a:defRPr>
@@ -1250,7 +1254,7 @@
           <a:lstStyle/>
           <a:p>
             <a:r>
-              <a:t>f5 · Weighted monthly churn by segment · churn_by_segment · main.cs.churn_monthly · statement duckdb-d6c07659062c · queried 2026-10-18 07:47 UTC</a:t>
+              <a:t>f5 · Weighted monthly churn by segment · churn_by_segment · main.cs.churn_monthly · statement duckdb-43afe7c4cb0c · queried 2026-10-18 08:06 UTC</a:t>
             </a:r>
           </a:p>
           <a:p>
@@ -1410,27 +1414,27 @@
           <a:lstStyle/>
           <a:p>
             <a:r>
-              <a:t>f1 · Monthly churn (weighted) · churn_rate_quarter · main.cs.churn_monthly · statement duckdb-ebb692d3fbc7 · queried 2026-10-18 07:47 UTC</a:t>
-            </a:r>
-          </a:p>
-          <a:p>
-            <a:r>
-              <a:t>f2 · Monthly NRR (weighted) · nrr_quarter · main.cs.revenue_monthly · statement duckdb-e19065def916 · queried 2026-10-18 07:47 UTC</a:t>
-            </a:r>
-          </a:p>
-          <a:p>
-            <a:r>
-              <a:t>f3 · Active subscriptions · active_subscriptions · main.cs.churn_monthly · statement duckdb-7e88f9eb3e88 · queried 2026-10-18 07:47 UTC</a:t>
-            </a:r>
-          </a:p>
-          <a:p>
-            <a:r>
-              <a:t>f4 · Monthly churn · churn_trend_monthly · main.cs.churn_monthly · statement duckdb-c0c3bc7ae458 · queried 2026-10-18 07:47 UTC</a:t>
-            </a:r>
-          </a:p>
-          <a:p>
-            <a:r>
-              <a:t>f5 · Weighted monthly churn by segment · churn_by_segment · main.cs.churn_monthly · statement duckdb-d6c07659062c · queried 2026-10-18 07:47 UTC</a:t>
+              <a:t>f1 · Monthly churn (weighted) · churn_rate_quarter · main.cs.churn_monthly · statement duckdb-16075aee0f1b · queried 2026-10-18 08:06 UTC</a:t>
+            </a:r>
+          </a:p>
+          <a:p>
+            <a:r>
+              <a:t>f2 · Monthly NRR (weighted) · nrr_quarter · main.cs.revenue_monthly · statement duckdb-f532014d0e5c · queried 2026-10-18 08:06 UTC</a:t>
+            </a:r>
+          </a:p>
+          <a:p>
+            <a:r>
+              <a:t>f3 · Active subscriptions · active_subscriptions · main.cs.churn_monthly · statement duckdb-71763ed1073a · queried 2026-10-18 08:06 UTC</a:t>
+            </a:r>
+          </a:p>
+          <a:p>
+            <a:r>
+              <a:t>f4 · Monthly churn · churn_trend_monthly · main.cs.churn_monthly · statement duckdb-b62d270f92c1 · queried 2026-10-18 08:06 UTC</a:t>
+            </a:r>
+          </a:p>
+          <a:p>
+            <a:r>
+              <a:t>f5 · Weighted monthly churn by segment · churn_by_segment · main.cs.churn_monthly · statement duckdb-43afe7c4cb0c · queried 2026-10-18 08:06 UTC</a:t>
             </a:r>
           </a:p>
           <a:p>
@@ -1670,22 +1674,22 @@
           <a:lstStyle/>
           <a:p>
             <a:r>
-              <a:t>f1 · Monthly churn (weighted) · churn_rate_quarter · main.cs.churn_monthly · statement duckdb-ebb692d3fbc7 · queried 2026-10-18 07:47 UTC</a:t>
-            </a:r>
-          </a:p>
-          <a:p>
-            <a:r>
-              <a:t>f2 · Monthly NRR (weighted) · nrr_quarter · main.cs.revenue_monthly · statement duckdb-e19065def916 · queried 2026-10-18 07:47 UTC</a:t>
-            </a:r>
-          </a:p>
-          <a:p>
-            <a:r>
-              <a:t>f3 · Active subscriptions · active_subscriptions · main.cs.churn_monthly · statement duckdb-7e88f9eb3e88 · queried 2026-10-18 07:47 UTC</a:t>
-            </a:r>
-          </a:p>
-          <a:p>
-            <a:r>
-              <a:t>f4 · Monthly churn · churn_trend_monthly · main.cs.churn_monthly · statement duckdb-c0c3bc7ae458 · queried 2026-10-18 07:47 UTC</a:t>
+              <a:t>f1 · Monthly churn (weighted) · churn_rate_quarter · main.cs.churn_monthly · statement duckdb-16075aee0f1b · queried 2026-10-18 08:06 UTC</a:t>
+            </a:r>
+          </a:p>
+          <a:p>
+            <a:r>
+              <a:t>f2 · Monthly NRR (weighted) · nrr_quarter · main.cs.revenue_monthly · statement duckdb-f532014d0e5c · queried 2026-10-18 08:06 UTC</a:t>
+            </a:r>
+          </a:p>
+          <a:p>
+            <a:r>
+              <a:t>f3 · Active subscriptions · active_subscriptions · main.cs.churn_monthly · statement duckdb-71763ed1073a · queried 2026-10-18 08:06 UTC</a:t>
+            </a:r>
+          </a:p>
+          <a:p>
+            <a:r>
+              <a:t>f4 · Monthly churn · churn_trend_monthly · main.cs.churn_monthly · statement duckdb-b62d270f92c1 · queried 2026-10-18 08:06 UTC</a:t>
             </a:r>
           </a:p>
           <a:p>
@@ -1835,7 +1839,7 @@
           <a:lstStyle/>
           <a:p>
             <a:r>
-              <a:t>f4 · Monthly churn · churn_trend_monthly · main.cs.churn_monthly · statement duckdb-c0c3bc7ae458 · queried 2026-10-18 07:47 UTC</a:t>
+              <a:t>f4 · Monthly churn · churn_trend_monthly · main.cs.churn_monthly · statement duckdb-b62d270f92c1 · queried 2026-10-18 08:06 UTC</a:t>
             </a:r>
           </a:p>
           <a:p>
@@ -1925,7 +1929,7 @@
           <a:lstStyle/>
           <a:p>
             <a:r>
-              <a:t>f5 · Weighted monthly churn by segment · churn_by_segment · main.cs.churn_monthly · statement duckdb-d6c07659062c · queried 2026-10-18 07:47 UTC</a:t>
+              <a:t>f5 · Weighted monthly churn by segment · churn_by_segment · main.cs.churn_monthly · statement duckdb-43afe7c4cb0c · queried 2026-10-18 08:06 UTC</a:t>
             </a:r>
           </a:p>
           <a:p>
@@ -6176,8 +6180,8 @@
         </p:nvSpPr>
         <p:spPr>
           <a:xfrm>
-            <a:off x="566928" y="1463040"/>
-            <a:ext cx="5611368" cy="4882896"/>
+            <a:off x="566928" y="2967228"/>
+            <a:ext cx="5611368" cy="1874520"/>
           </a:xfrm>
           <a:prstGeom prst="roundRect">
             <a:avLst>
@@ -6221,8 +6225,8 @@
         </p:nvSpPr>
         <p:spPr>
           <a:xfrm>
-            <a:off x="566928" y="1463040"/>
-            <a:ext cx="5611368" cy="640080"/>
+            <a:off x="566928" y="2967228"/>
+            <a:ext cx="5611368" cy="502920"/>
           </a:xfrm>
           <a:prstGeom prst="rect">
             <a:avLst/>
@@ -6264,8 +6268,8 @@
         </p:nvSpPr>
         <p:spPr>
           <a:xfrm>
-            <a:off x="749808" y="1463040"/>
-            <a:ext cx="5245608" cy="640080"/>
+            <a:off x="749808" y="2967228"/>
+            <a:ext cx="5245608" cy="502920"/>
           </a:xfrm>
           <a:prstGeom prst="rect">
             <a:avLst/>
@@ -6307,7 +6311,7 @@
         </p:nvSpPr>
         <p:spPr>
           <a:xfrm>
-            <a:off x="749808" y="3136392"/>
+            <a:off x="749808" y="3785616"/>
             <a:ext cx="54864" cy="54864"/>
           </a:xfrm>
           <a:prstGeom prst="ellipse">
@@ -6350,8 +6354,8 @@
         </p:nvSpPr>
         <p:spPr>
           <a:xfrm>
-            <a:off x="886968" y="2103120"/>
-            <a:ext cx="5154168" cy="2121408"/>
+            <a:off x="886968" y="3470148"/>
+            <a:ext cx="5154168" cy="685800"/>
           </a:xfrm>
           <a:prstGeom prst="rect">
             <a:avLst/>
@@ -6393,7 +6397,7 @@
         </p:nvSpPr>
         <p:spPr>
           <a:xfrm>
-            <a:off x="749808" y="5257800"/>
+            <a:off x="749808" y="4471416"/>
             <a:ext cx="54864" cy="54864"/>
           </a:xfrm>
           <a:prstGeom prst="ellipse">
@@ -6436,8 +6440,8 @@
         </p:nvSpPr>
         <p:spPr>
           <a:xfrm>
-            <a:off x="886968" y="4224528"/>
-            <a:ext cx="5154168" cy="2121408"/>
+            <a:off x="886968" y="4155948"/>
+            <a:ext cx="5154168" cy="685800"/>
           </a:xfrm>
           <a:prstGeom prst="rect">
             <a:avLst/>
@@ -6479,8 +6483,8 @@
         </p:nvSpPr>
         <p:spPr>
           <a:xfrm>
-            <a:off x="6178296" y="1463040"/>
-            <a:ext cx="5446776" cy="4882896"/>
+            <a:off x="6178296" y="2967228"/>
+            <a:ext cx="5446776" cy="1874520"/>
           </a:xfrm>
           <a:prstGeom prst="roundRect">
             <a:avLst>
@@ -6524,8 +6528,8 @@
         </p:nvSpPr>
         <p:spPr>
           <a:xfrm>
-            <a:off x="6178296" y="1463040"/>
-            <a:ext cx="5446776" cy="640080"/>
+            <a:off x="6178296" y="2967228"/>
+            <a:ext cx="5446776" cy="502920"/>
           </a:xfrm>
           <a:prstGeom prst="rect">
             <a:avLst/>
@@ -6567,8 +6571,8 @@
         </p:nvSpPr>
         <p:spPr>
           <a:xfrm>
-            <a:off x="6361176" y="1463040"/>
-            <a:ext cx="5081016" cy="640080"/>
+            <a:off x="6361176" y="2967228"/>
+            <a:ext cx="5081016" cy="502920"/>
           </a:xfrm>
           <a:prstGeom prst="rect">
             <a:avLst/>
@@ -6610,7 +6614,7 @@
         </p:nvSpPr>
         <p:spPr>
           <a:xfrm>
-            <a:off x="6361176" y="3136392"/>
+            <a:off x="6361176" y="3785616"/>
             <a:ext cx="54864" cy="54864"/>
           </a:xfrm>
           <a:prstGeom prst="ellipse">
@@ -6653,8 +6657,8 @@
         </p:nvSpPr>
         <p:spPr>
           <a:xfrm>
-            <a:off x="6498336" y="2103120"/>
-            <a:ext cx="4989576" cy="2121408"/>
+            <a:off x="6498336" y="3470148"/>
+            <a:ext cx="4989576" cy="685800"/>
           </a:xfrm>
           <a:prstGeom prst="rect">
             <a:avLst/>
@@ -6696,7 +6700,7 @@
         </p:nvSpPr>
         <p:spPr>
           <a:xfrm>
-            <a:off x="6361176" y="5257800"/>
+            <a:off x="6361176" y="4471416"/>
             <a:ext cx="54864" cy="54864"/>
           </a:xfrm>
           <a:prstGeom prst="ellipse">
@@ -6739,8 +6743,8 @@
         </p:nvSpPr>
         <p:spPr>
           <a:xfrm>
-            <a:off x="6498336" y="4224528"/>
-            <a:ext cx="4989576" cy="2121408"/>
+            <a:off x="6498336" y="4155948"/>
+            <a:ext cx="4989576" cy="685800"/>
           </a:xfrm>
           <a:prstGeom prst="rect">
             <a:avLst/>
@@ -7780,8 +7784,8 @@
         </p:nvSpPr>
         <p:spPr>
           <a:xfrm>
-            <a:off x="566928" y="1463040"/>
-            <a:ext cx="3740912" cy="4882896"/>
+            <a:off x="566928" y="2852928"/>
+            <a:ext cx="3740912" cy="2103120"/>
           </a:xfrm>
           <a:prstGeom prst="roundRect">
             <a:avLst>
@@ -7825,8 +7829,8 @@
         </p:nvSpPr>
         <p:spPr>
           <a:xfrm>
-            <a:off x="566928" y="1463040"/>
-            <a:ext cx="3740912" cy="54864"/>
+            <a:off x="566928" y="2852928"/>
+            <a:ext cx="3740912" cy="45720"/>
           </a:xfrm>
           <a:prstGeom prst="rect">
             <a:avLst/>
@@ -7868,8 +7872,8 @@
         </p:nvSpPr>
         <p:spPr>
           <a:xfrm>
-            <a:off x="749808" y="1691640"/>
-            <a:ext cx="3375152" cy="1097280"/>
+            <a:off x="749808" y="2990088"/>
+            <a:ext cx="3375152" cy="822960"/>
           </a:xfrm>
           <a:prstGeom prst="rect">
             <a:avLst/>
@@ -7892,7 +7896,7 @@
               </a:spcAft>
             </a:pPr>
             <a:r>
-              <a:rPr sz="4400" b="1">
+              <a:rPr sz="4000" b="1">
                 <a:solidFill>
                   <a:srgbClr val="1D4ED8"/>
                 </a:solidFill>
@@ -7911,7 +7915,7 @@
         </p:nvSpPr>
         <p:spPr>
           <a:xfrm>
-            <a:off x="749808" y="2834640"/>
+            <a:off x="749808" y="3904488"/>
             <a:ext cx="457200" cy="27432"/>
           </a:xfrm>
           <a:prstGeom prst="rect">
@@ -7954,8 +7958,8 @@
         </p:nvSpPr>
         <p:spPr>
           <a:xfrm>
-            <a:off x="749808" y="3017520"/>
-            <a:ext cx="3375152" cy="3054096"/>
+            <a:off x="749808" y="3995928"/>
+            <a:ext cx="3375152" cy="822960"/>
           </a:xfrm>
           <a:prstGeom prst="rect">
             <a:avLst/>
@@ -7978,13 +7982,13 @@
               </a:spcAft>
             </a:pPr>
             <a:r>
-              <a:rPr sz="2200" b="0">
+              <a:rPr sz="2000" b="0">
                 <a:solidFill>
                   <a:srgbClr val="111113"/>
                 </a:solidFill>
                 <a:latin typeface="Calibri"/>
               </a:rPr>
-              <a:t>The headline figures</a:t>
+              <a:t>The headline figures frame</a:t>
             </a:r>
           </a:p>
           <a:p>
@@ -8000,13 +8004,13 @@
               </a:spcAft>
             </a:pPr>
             <a:r>
-              <a:rPr sz="2200" b="0">
+              <a:rPr sz="2000" b="0">
                 <a:solidFill>
                   <a:srgbClr val="111113"/>
                 </a:solidFill>
                 <a:latin typeface="Calibri"/>
               </a:rPr>
-              <a:t>frame the review</a:t>
+              <a:t>the review</a:t>
             </a:r>
           </a:p>
         </p:txBody>
@@ -8019,8 +8023,8 @@
         </p:nvSpPr>
         <p:spPr>
           <a:xfrm>
-            <a:off x="4307840" y="1463040"/>
-            <a:ext cx="3740912" cy="4882896"/>
+            <a:off x="4307840" y="2852928"/>
+            <a:ext cx="3740912" cy="2103120"/>
           </a:xfrm>
           <a:prstGeom prst="roundRect">
             <a:avLst>
@@ -8064,8 +8068,8 @@
         </p:nvSpPr>
         <p:spPr>
           <a:xfrm>
-            <a:off x="4307840" y="1463040"/>
-            <a:ext cx="3740912" cy="54864"/>
+            <a:off x="4307840" y="2852928"/>
+            <a:ext cx="3740912" cy="45720"/>
           </a:xfrm>
           <a:prstGeom prst="rect">
             <a:avLst/>
@@ -8107,8 +8111,8 @@
         </p:nvSpPr>
         <p:spPr>
           <a:xfrm>
-            <a:off x="4490720" y="1691640"/>
-            <a:ext cx="3375152" cy="1097280"/>
+            <a:off x="4490720" y="2990088"/>
+            <a:ext cx="3375152" cy="822960"/>
           </a:xfrm>
           <a:prstGeom prst="rect">
             <a:avLst/>
@@ -8131,7 +8135,7 @@
               </a:spcAft>
             </a:pPr>
             <a:r>
-              <a:rPr sz="4400" b="1">
+              <a:rPr sz="4000" b="1">
                 <a:solidFill>
                   <a:srgbClr val="1D4ED8"/>
                 </a:solidFill>
@@ -8150,7 +8154,7 @@
         </p:nvSpPr>
         <p:spPr>
           <a:xfrm>
-            <a:off x="4490720" y="2834640"/>
+            <a:off x="4490720" y="3904488"/>
             <a:ext cx="457200" cy="27432"/>
           </a:xfrm>
           <a:prstGeom prst="rect">
@@ -8193,8 +8197,8 @@
         </p:nvSpPr>
         <p:spPr>
           <a:xfrm>
-            <a:off x="4490720" y="3017520"/>
-            <a:ext cx="3375152" cy="3054096"/>
+            <a:off x="4490720" y="3995928"/>
+            <a:ext cx="3375152" cy="822960"/>
           </a:xfrm>
           <a:prstGeom prst="rect">
             <a:avLst/>
@@ -8217,13 +8221,13 @@
               </a:spcAft>
             </a:pPr>
             <a:r>
-              <a:rPr sz="2200" b="0">
+              <a:rPr sz="2000" b="0">
                 <a:solidFill>
                   <a:srgbClr val="111113"/>
                 </a:solidFill>
                 <a:latin typeface="Calibri"/>
               </a:rPr>
-              <a:t>The monthly path shows</a:t>
+              <a:t>The monthly path shows the</a:t>
             </a:r>
           </a:p>
           <a:p>
@@ -8239,13 +8243,13 @@
               </a:spcAft>
             </a:pPr>
             <a:r>
-              <a:rPr sz="2200" b="0">
+              <a:rPr sz="2000" b="0">
                 <a:solidFill>
                   <a:srgbClr val="111113"/>
                 </a:solidFill>
                 <a:latin typeface="Calibri"/>
               </a:rPr>
-              <a:t>the direction</a:t>
+              <a:t>direction</a:t>
             </a:r>
           </a:p>
         </p:txBody>
@@ -8258,8 +8262,8 @@
         </p:nvSpPr>
         <p:spPr>
           <a:xfrm>
-            <a:off x="8048752" y="1463040"/>
-            <a:ext cx="3576320" cy="4882896"/>
+            <a:off x="8048752" y="2852928"/>
+            <a:ext cx="3576320" cy="2103120"/>
           </a:xfrm>
           <a:prstGeom prst="roundRect">
             <a:avLst>
@@ -8303,8 +8307,8 @@
         </p:nvSpPr>
         <p:spPr>
           <a:xfrm>
-            <a:off x="8048752" y="1463040"/>
-            <a:ext cx="3576320" cy="54864"/>
+            <a:off x="8048752" y="2852928"/>
+            <a:ext cx="3576320" cy="45720"/>
           </a:xfrm>
           <a:prstGeom prst="rect">
             <a:avLst/>
@@ -8346,8 +8350,8 @@
         </p:nvSpPr>
         <p:spPr>
           <a:xfrm>
-            <a:off x="8231632" y="1691640"/>
-            <a:ext cx="3210560" cy="1097280"/>
+            <a:off x="8231632" y="2990088"/>
+            <a:ext cx="3210560" cy="822960"/>
           </a:xfrm>
           <a:prstGeom prst="rect">
             <a:avLst/>
@@ -8370,7 +8374,7 @@
               </a:spcAft>
             </a:pPr>
             <a:r>
-              <a:rPr sz="4400" b="1">
+              <a:rPr sz="4000" b="1">
                 <a:solidFill>
                   <a:srgbClr val="1D4ED8"/>
                 </a:solidFill>
@@ -8389,7 +8393,7 @@
         </p:nvSpPr>
         <p:spPr>
           <a:xfrm>
-            <a:off x="8231632" y="2834640"/>
+            <a:off x="8231632" y="3904488"/>
             <a:ext cx="457200" cy="27432"/>
           </a:xfrm>
           <a:prstGeom prst="rect">
@@ -8432,8 +8436,8 @@
         </p:nvSpPr>
         <p:spPr>
           <a:xfrm>
-            <a:off x="8231632" y="3017520"/>
-            <a:ext cx="3210560" cy="3054096"/>
+            <a:off x="8231632" y="3995928"/>
+            <a:ext cx="3210560" cy="822960"/>
           </a:xfrm>
           <a:prstGeom prst="rect">
             <a:avLst/>
@@ -8456,13 +8460,13 @@
               </a:spcAft>
             </a:pPr>
             <a:r>
-              <a:rPr sz="2200" b="0">
+              <a:rPr sz="2000" b="0">
                 <a:solidFill>
                   <a:srgbClr val="111113"/>
                 </a:solidFill>
                 <a:latin typeface="Calibri"/>
               </a:rPr>
-              <a:t>The segment split</a:t>
+              <a:t>The segment split shows</a:t>
             </a:r>
           </a:p>
           <a:p>
@@ -8478,13 +8482,13 @@
               </a:spcAft>
             </a:pPr>
             <a:r>
-              <a:rPr sz="2200" b="0">
+              <a:rPr sz="2000" b="0">
                 <a:solidFill>
                   <a:srgbClr val="111113"/>
                 </a:solidFill>
                 <a:latin typeface="Calibri"/>
               </a:rPr>
-              <a:t>shows where it sits</a:t>
+              <a:t>where it sits</a:t>
             </a:r>
           </a:p>
         </p:txBody>
@@ -12425,8 +12429,8 @@
         </p:nvSpPr>
         <p:spPr>
           <a:xfrm>
-            <a:off x="566928" y="1463040"/>
-            <a:ext cx="5611368" cy="4882896"/>
+            <a:off x="566928" y="2967228"/>
+            <a:ext cx="5611368" cy="1874520"/>
           </a:xfrm>
           <a:prstGeom prst="roundRect">
             <a:avLst>
@@ -12470,8 +12474,8 @@
         </p:nvSpPr>
         <p:spPr>
           <a:xfrm>
-            <a:off x="566928" y="1463040"/>
-            <a:ext cx="5611368" cy="640080"/>
+            <a:off x="566928" y="2967228"/>
+            <a:ext cx="5611368" cy="502920"/>
           </a:xfrm>
           <a:prstGeom prst="rect">
             <a:avLst/>
@@ -12513,8 +12517,8 @@
         </p:nvSpPr>
         <p:spPr>
           <a:xfrm>
-            <a:off x="704088" y="1463040"/>
-            <a:ext cx="640080" cy="640080"/>
+            <a:off x="704088" y="2967228"/>
+            <a:ext cx="640080" cy="502920"/>
           </a:xfrm>
           <a:prstGeom prst="rect">
             <a:avLst/>
@@ -12556,8 +12560,8 @@
         </p:nvSpPr>
         <p:spPr>
           <a:xfrm>
-            <a:off x="1344168" y="1463040"/>
-            <a:ext cx="4651248" cy="640080"/>
+            <a:off x="1344168" y="2967228"/>
+            <a:ext cx="4651248" cy="502920"/>
           </a:xfrm>
           <a:prstGeom prst="rect">
             <a:avLst/>
@@ -12599,7 +12603,7 @@
         </p:nvSpPr>
         <p:spPr>
           <a:xfrm>
-            <a:off x="749808" y="3136392"/>
+            <a:off x="749808" y="3785616"/>
             <a:ext cx="54864" cy="54864"/>
           </a:xfrm>
           <a:prstGeom prst="ellipse">
@@ -12642,8 +12646,8 @@
         </p:nvSpPr>
         <p:spPr>
           <a:xfrm>
-            <a:off x="886968" y="2103120"/>
-            <a:ext cx="5154168" cy="2121408"/>
+            <a:off x="886968" y="3470148"/>
+            <a:ext cx="5154168" cy="685800"/>
           </a:xfrm>
           <a:prstGeom prst="rect">
             <a:avLst/>
@@ -12685,7 +12689,7 @@
         </p:nvSpPr>
         <p:spPr>
           <a:xfrm>
-            <a:off x="749808" y="5257800"/>
+            <a:off x="749808" y="4471416"/>
             <a:ext cx="54864" cy="54864"/>
           </a:xfrm>
           <a:prstGeom prst="ellipse">
@@ -12728,8 +12732,8 @@
         </p:nvSpPr>
         <p:spPr>
           <a:xfrm>
-            <a:off x="886968" y="4224528"/>
-            <a:ext cx="5154168" cy="2121408"/>
+            <a:off x="886968" y="4155948"/>
+            <a:ext cx="5154168" cy="685800"/>
           </a:xfrm>
           <a:prstGeom prst="rect">
             <a:avLst/>
@@ -12771,8 +12775,8 @@
         </p:nvSpPr>
         <p:spPr>
           <a:xfrm>
-            <a:off x="6178296" y="1463040"/>
-            <a:ext cx="5446776" cy="4882896"/>
+            <a:off x="6178296" y="2967228"/>
+            <a:ext cx="5446776" cy="1874520"/>
           </a:xfrm>
           <a:prstGeom prst="roundRect">
             <a:avLst>
@@ -12816,8 +12820,8 @@
         </p:nvSpPr>
         <p:spPr>
           <a:xfrm>
-            <a:off x="6178296" y="1463040"/>
-            <a:ext cx="5446776" cy="640080"/>
+            <a:off x="6178296" y="2967228"/>
+            <a:ext cx="5446776" cy="502920"/>
           </a:xfrm>
           <a:prstGeom prst="rect">
             <a:avLst/>
@@ -12859,8 +12863,8 @@
         </p:nvSpPr>
         <p:spPr>
           <a:xfrm>
-            <a:off x="6315456" y="1463040"/>
-            <a:ext cx="640080" cy="640080"/>
+            <a:off x="6315456" y="2967228"/>
+            <a:ext cx="640080" cy="502920"/>
           </a:xfrm>
           <a:prstGeom prst="rect">
             <a:avLst/>
@@ -12902,8 +12906,8 @@
         </p:nvSpPr>
         <p:spPr>
           <a:xfrm>
-            <a:off x="6955536" y="1463040"/>
-            <a:ext cx="4486656" cy="640080"/>
+            <a:off x="6955536" y="2967228"/>
+            <a:ext cx="4486656" cy="502920"/>
           </a:xfrm>
           <a:prstGeom prst="rect">
             <a:avLst/>
@@ -12945,7 +12949,7 @@
         </p:nvSpPr>
         <p:spPr>
           <a:xfrm>
-            <a:off x="6361176" y="3136392"/>
+            <a:off x="6361176" y="3785616"/>
             <a:ext cx="54864" cy="54864"/>
           </a:xfrm>
           <a:prstGeom prst="ellipse">
@@ -12988,8 +12992,8 @@
         </p:nvSpPr>
         <p:spPr>
           <a:xfrm>
-            <a:off x="6498336" y="2103120"/>
-            <a:ext cx="4989576" cy="2121408"/>
+            <a:off x="6498336" y="3470148"/>
+            <a:ext cx="4989576" cy="685800"/>
           </a:xfrm>
           <a:prstGeom prst="rect">
             <a:avLst/>
@@ -13031,7 +13035,7 @@
         </p:nvSpPr>
         <p:spPr>
           <a:xfrm>
-            <a:off x="6361176" y="5257800"/>
+            <a:off x="6361176" y="4471416"/>
             <a:ext cx="54864" cy="54864"/>
           </a:xfrm>
           <a:prstGeom prst="ellipse">
@@ -13074,8 +13078,8 @@
         </p:nvSpPr>
         <p:spPr>
           <a:xfrm>
-            <a:off x="6498336" y="4224528"/>
-            <a:ext cx="4989576" cy="2121408"/>
+            <a:off x="6498336" y="4155948"/>
+            <a:ext cx="4989576" cy="685800"/>
           </a:xfrm>
           <a:prstGeom prst="rect">
             <a:avLst/>
@@ -13358,7 +13362,7 @@
         </p:nvSpPr>
         <p:spPr>
           <a:xfrm>
-            <a:off x="566928" y="1828800"/>
+            <a:off x="566928" y="3035808"/>
             <a:ext cx="11058144" cy="27432"/>
           </a:xfrm>
           <a:prstGeom prst="rect">
@@ -13401,8 +13405,8 @@
         </p:nvSpPr>
         <p:spPr>
           <a:xfrm>
-            <a:off x="566928" y="1554480"/>
-            <a:ext cx="2641092" cy="4791456"/>
+            <a:off x="566928" y="2807208"/>
+            <a:ext cx="2641092" cy="2194560"/>
           </a:xfrm>
           <a:prstGeom prst="roundRect">
             <a:avLst>
@@ -13446,7 +13450,7 @@
         </p:nvSpPr>
         <p:spPr>
           <a:xfrm>
-            <a:off x="749808" y="1783080"/>
+            <a:off x="749808" y="2990088"/>
             <a:ext cx="137160" cy="137160"/>
           </a:xfrm>
           <a:prstGeom prst="ellipse">
@@ -13489,7 +13493,7 @@
         </p:nvSpPr>
         <p:spPr>
           <a:xfrm>
-            <a:off x="932688" y="1691640"/>
+            <a:off x="932688" y="2944368"/>
             <a:ext cx="2138172" cy="411480"/>
           </a:xfrm>
           <a:prstGeom prst="rect">
@@ -13532,8 +13536,8 @@
         </p:nvSpPr>
         <p:spPr>
           <a:xfrm>
-            <a:off x="726948" y="2194560"/>
-            <a:ext cx="2321052" cy="731520"/>
+            <a:off x="726948" y="3401568"/>
+            <a:ext cx="2321052" cy="548640"/>
           </a:xfrm>
           <a:prstGeom prst="rect">
             <a:avLst/>
@@ -13541,7 +13545,7 @@
           <a:noFill/>
         </p:spPr>
         <p:txBody>
-          <a:bodyPr wrap="square" lIns="0" rIns="0" tIns="0" bIns="0" anchor="t"/>
+          <a:bodyPr wrap="square" lIns="0" rIns="0" tIns="0" bIns="0" anchor="ctr"/>
           <a:lstStyle/>
           <a:p>
             <a:pPr algn="l">
@@ -13575,7 +13579,7 @@
         </p:nvSpPr>
         <p:spPr>
           <a:xfrm>
-            <a:off x="726948" y="4677156"/>
+            <a:off x="726948" y="4041648"/>
             <a:ext cx="365760" cy="27432"/>
           </a:xfrm>
           <a:prstGeom prst="rect">
@@ -13618,8 +13622,8 @@
         </p:nvSpPr>
         <p:spPr>
           <a:xfrm>
-            <a:off x="726948" y="4814316"/>
-            <a:ext cx="2321052" cy="1371600"/>
+            <a:off x="726948" y="4133088"/>
+            <a:ext cx="2321052" cy="685800"/>
           </a:xfrm>
           <a:prstGeom prst="rect">
             <a:avLst/>
@@ -13683,8 +13687,8 @@
         </p:nvSpPr>
         <p:spPr>
           <a:xfrm>
-            <a:off x="3372612" y="1554480"/>
-            <a:ext cx="2641092" cy="4791456"/>
+            <a:off x="3372612" y="2807208"/>
+            <a:ext cx="2641092" cy="2194560"/>
           </a:xfrm>
           <a:prstGeom prst="roundRect">
             <a:avLst>
@@ -13728,7 +13732,7 @@
         </p:nvSpPr>
         <p:spPr>
           <a:xfrm>
-            <a:off x="3555492" y="1783080"/>
+            <a:off x="3555492" y="2990088"/>
             <a:ext cx="137160" cy="137160"/>
           </a:xfrm>
           <a:prstGeom prst="ellipse">
@@ -13771,7 +13775,7 @@
         </p:nvSpPr>
         <p:spPr>
           <a:xfrm>
-            <a:off x="3738372" y="1691640"/>
+            <a:off x="3738372" y="2944368"/>
             <a:ext cx="2138172" cy="411480"/>
           </a:xfrm>
           <a:prstGeom prst="rect">
@@ -13814,8 +13818,8 @@
         </p:nvSpPr>
         <p:spPr>
           <a:xfrm>
-            <a:off x="3532632" y="2194560"/>
-            <a:ext cx="2321052" cy="731520"/>
+            <a:off x="3532632" y="3401568"/>
+            <a:ext cx="2321052" cy="548640"/>
           </a:xfrm>
           <a:prstGeom prst="rect">
             <a:avLst/>
@@ -13823,7 +13827,7 @@
           <a:noFill/>
         </p:spPr>
         <p:txBody>
-          <a:bodyPr wrap="square" lIns="0" rIns="0" tIns="0" bIns="0" anchor="t"/>
+          <a:bodyPr wrap="square" lIns="0" rIns="0" tIns="0" bIns="0" anchor="ctr"/>
           <a:lstStyle/>
           <a:p>
             <a:pPr algn="l">
@@ -13857,7 +13861,7 @@
         </p:nvSpPr>
         <p:spPr>
           <a:xfrm>
-            <a:off x="3532632" y="4677156"/>
+            <a:off x="3532632" y="4041648"/>
             <a:ext cx="365760" cy="27432"/>
           </a:xfrm>
           <a:prstGeom prst="rect">
@@ -13900,8 +13904,8 @@
         </p:nvSpPr>
         <p:spPr>
           <a:xfrm>
-            <a:off x="3532632" y="4814316"/>
-            <a:ext cx="2321052" cy="1371600"/>
+            <a:off x="3532632" y="4133088"/>
+            <a:ext cx="2321052" cy="685800"/>
           </a:xfrm>
           <a:prstGeom prst="rect">
             <a:avLst/>
@@ -13943,8 +13947,8 @@
         </p:nvSpPr>
         <p:spPr>
           <a:xfrm>
-            <a:off x="6178296" y="1554480"/>
-            <a:ext cx="2641092" cy="4791456"/>
+            <a:off x="6178296" y="2807208"/>
+            <a:ext cx="2641092" cy="2194560"/>
           </a:xfrm>
           <a:prstGeom prst="roundRect">
             <a:avLst>
@@ -13988,7 +13992,7 @@
         </p:nvSpPr>
         <p:spPr>
           <a:xfrm>
-            <a:off x="6361176" y="1783080"/>
+            <a:off x="6361176" y="2990088"/>
             <a:ext cx="137160" cy="137160"/>
           </a:xfrm>
           <a:prstGeom prst="ellipse">
@@ -14031,7 +14035,7 @@
         </p:nvSpPr>
         <p:spPr>
           <a:xfrm>
-            <a:off x="6544056" y="1691640"/>
+            <a:off x="6544056" y="2944368"/>
             <a:ext cx="2138172" cy="411480"/>
           </a:xfrm>
           <a:prstGeom prst="rect">
@@ -14074,8 +14078,8 @@
         </p:nvSpPr>
         <p:spPr>
           <a:xfrm>
-            <a:off x="6338316" y="2194560"/>
-            <a:ext cx="2321052" cy="731520"/>
+            <a:off x="6338316" y="3401568"/>
+            <a:ext cx="2321052" cy="548640"/>
           </a:xfrm>
           <a:prstGeom prst="rect">
             <a:avLst/>
@@ -14083,7 +14087,7 @@
           <a:noFill/>
         </p:spPr>
         <p:txBody>
-          <a:bodyPr wrap="square" lIns="0" rIns="0" tIns="0" bIns="0" anchor="t"/>
+          <a:bodyPr wrap="square" lIns="0" rIns="0" tIns="0" bIns="0" anchor="ctr"/>
           <a:lstStyle/>
           <a:p>
             <a:pPr algn="l">
@@ -14117,7 +14121,7 @@
         </p:nvSpPr>
         <p:spPr>
           <a:xfrm>
-            <a:off x="6338316" y="4677156"/>
+            <a:off x="6338316" y="4041648"/>
             <a:ext cx="365760" cy="27432"/>
           </a:xfrm>
           <a:prstGeom prst="rect">
@@ -14160,8 +14164,8 @@
         </p:nvSpPr>
         <p:spPr>
           <a:xfrm>
-            <a:off x="6338316" y="4814316"/>
-            <a:ext cx="2321052" cy="1371600"/>
+            <a:off x="6338316" y="4133088"/>
+            <a:ext cx="2321052" cy="685800"/>
           </a:xfrm>
           <a:prstGeom prst="rect">
             <a:avLst/>
@@ -14203,8 +14207,8 @@
         </p:nvSpPr>
         <p:spPr>
           <a:xfrm>
-            <a:off x="8983980" y="1554480"/>
-            <a:ext cx="2641092" cy="4791456"/>
+            <a:off x="8983980" y="2807208"/>
+            <a:ext cx="2641092" cy="2194560"/>
           </a:xfrm>
           <a:prstGeom prst="roundRect">
             <a:avLst>
@@ -14248,7 +14252,7 @@
         </p:nvSpPr>
         <p:spPr>
           <a:xfrm>
-            <a:off x="9166860" y="1783080"/>
+            <a:off x="9166860" y="2990088"/>
             <a:ext cx="137160" cy="137160"/>
           </a:xfrm>
           <a:prstGeom prst="ellipse">
@@ -14291,7 +14295,7 @@
         </p:nvSpPr>
         <p:spPr>
           <a:xfrm>
-            <a:off x="9349740" y="1691640"/>
+            <a:off x="9349740" y="2944368"/>
             <a:ext cx="2138172" cy="411480"/>
           </a:xfrm>
           <a:prstGeom prst="rect">
@@ -14334,8 +14338,8 @@
         </p:nvSpPr>
         <p:spPr>
           <a:xfrm>
-            <a:off x="9144000" y="2194560"/>
-            <a:ext cx="2321052" cy="731520"/>
+            <a:off x="9144000" y="3401568"/>
+            <a:ext cx="2321052" cy="548640"/>
           </a:xfrm>
           <a:prstGeom prst="rect">
             <a:avLst/>
@@ -14343,7 +14347,7 @@
           <a:noFill/>
         </p:spPr>
         <p:txBody>
-          <a:bodyPr wrap="square" lIns="0" rIns="0" tIns="0" bIns="0" anchor="t"/>
+          <a:bodyPr wrap="square" lIns="0" rIns="0" tIns="0" bIns="0" anchor="ctr"/>
           <a:lstStyle/>
           <a:p>
             <a:pPr algn="l">
@@ -14377,7 +14381,7 @@
         </p:nvSpPr>
         <p:spPr>
           <a:xfrm>
-            <a:off x="9144000" y="4677156"/>
+            <a:off x="9144000" y="4041648"/>
             <a:ext cx="365760" cy="27432"/>
           </a:xfrm>
           <a:prstGeom prst="rect">
@@ -14420,8 +14424,8 @@
         </p:nvSpPr>
         <p:spPr>
           <a:xfrm>
-            <a:off x="9144000" y="4814316"/>
-            <a:ext cx="2321052" cy="1371600"/>
+            <a:off x="9144000" y="4133088"/>
+            <a:ext cx="2321052" cy="685800"/>
           </a:xfrm>
           <a:prstGeom prst="rect">
             <a:avLst/>

</xml_diff>